<commit_message>
Fix pitch deck hero and policy comparison
</commit_message>
<xml_diff>
--- a/docs/Niyam-Hackathon-Pitch-Deck.pptx
+++ b/docs/Niyam-Hackathon-Pitch-Deck.pptx
@@ -2,19 +2,19 @@
 <file path=ppt/presentation.xml><?xml version="1.0" encoding="utf-8"?>
 <p:presentation xmlns:p="http://schemas.openxmlformats.org/presentationml/2006/main">
   <p:sldMasterIdLst>
-    <p:sldMasterId xmlns:r="http://schemas.openxmlformats.org/officeDocument/2006/relationships" id="2147483648" r:id="R6343ec536aac4c81"/>
+    <p:sldMasterId xmlns:r="http://schemas.openxmlformats.org/officeDocument/2006/relationships" id="2147483648" r:id="R58cd009615f84382"/>
   </p:sldMasterIdLst>
   <p:notesMasterIdLst>
-    <p:notesMasterId xmlns:r="http://schemas.openxmlformats.org/officeDocument/2006/relationships" r:id="R5f80f6f8f7ce48a2"/>
+    <p:notesMasterId xmlns:r="http://schemas.openxmlformats.org/officeDocument/2006/relationships" r:id="Rc6b27d0e3b9b44cc"/>
   </p:notesMasterIdLst>
   <p:sldIdLst>
-    <p:sldId xmlns:r="http://schemas.openxmlformats.org/officeDocument/2006/relationships" id="256" r:id="R747f6377f3674636"/>
-    <p:sldId xmlns:r="http://schemas.openxmlformats.org/officeDocument/2006/relationships" id="257" r:id="Ra5dce2967bad4a6b"/>
-    <p:sldId xmlns:r="http://schemas.openxmlformats.org/officeDocument/2006/relationships" id="258" r:id="R37518e28430d47af"/>
-    <p:sldId xmlns:r="http://schemas.openxmlformats.org/officeDocument/2006/relationships" id="259" r:id="R66d6180ddd774808"/>
-    <p:sldId xmlns:r="http://schemas.openxmlformats.org/officeDocument/2006/relationships" id="260" r:id="R60b910166d4a4678"/>
-    <p:sldId xmlns:r="http://schemas.openxmlformats.org/officeDocument/2006/relationships" id="261" r:id="R952a0c7aab164330"/>
-    <p:sldId xmlns:r="http://schemas.openxmlformats.org/officeDocument/2006/relationships" id="262" r:id="R12c21c38ec674e27"/>
+    <p:sldId xmlns:r="http://schemas.openxmlformats.org/officeDocument/2006/relationships" id="256" r:id="R1915f51854c2478d"/>
+    <p:sldId xmlns:r="http://schemas.openxmlformats.org/officeDocument/2006/relationships" id="257" r:id="Rdf228b18c1114682"/>
+    <p:sldId xmlns:r="http://schemas.openxmlformats.org/officeDocument/2006/relationships" id="258" r:id="Ra57449caf1ca4b27"/>
+    <p:sldId xmlns:r="http://schemas.openxmlformats.org/officeDocument/2006/relationships" id="259" r:id="R51b3d8344dc749c1"/>
+    <p:sldId xmlns:r="http://schemas.openxmlformats.org/officeDocument/2006/relationships" id="260" r:id="R1aa6fd4d79ae471d"/>
+    <p:sldId xmlns:r="http://schemas.openxmlformats.org/officeDocument/2006/relationships" id="261" r:id="Rcdcc719bfb244893"/>
+    <p:sldId xmlns:r="http://schemas.openxmlformats.org/officeDocument/2006/relationships" id="262" r:id="R96b2b06442f34585"/>
   </p:sldIdLst>
   <p:sldSz cx="12192000" cy="6858000"/>
   <p:notesSz cx="6858000" cy="9144000"/>
@@ -1003,7 +1003,7 @@
   </p:cSld>
   <p:clrMap bg1="lt1" tx1="dk1" bg2="lt2" tx2="dk2" accent1="accent1" accent2="accent2" accent3="accent3" accent4="accent4" accent5="accent5" accent6="accent6" hlink="hlink" folHlink="folHlink"/>
   <p:sldLayoutIdLst>
-    <p:sldLayoutId xmlns:r="http://schemas.openxmlformats.org/officeDocument/2006/relationships" id="2147483649" r:id="R6b321c72efde4313"/>
+    <p:sldLayoutId xmlns:r="http://schemas.openxmlformats.org/officeDocument/2006/relationships" id="2147483649" r:id="R2679409781c94dde"/>
   </p:sldLayoutIdLst>
   <p:txStyles>
     <p:titleStyle>
@@ -1565,8 +1565,8 @@
         </p:nvSpPr>
         <p:spPr>
           <a:xfrm xmlns:a="http://schemas.openxmlformats.org/drawingml/2006/main">
-            <a:off x="6115050" y="381000"/>
-            <a:ext cx="5619750" cy="5810250"/>
+            <a:off x="6115050" y="1368447"/>
+            <a:ext cx="5619750" cy="3835355"/>
           </a:xfrm>
           <a:prstGeom xmlns:a="http://schemas.openxmlformats.org/drawingml/2006/main" prst="roundRect">
             <a:avLst>
@@ -1614,6 +1614,7 @@
           <a:lstStyle xmlns:a="http://schemas.openxmlformats.org/drawingml/2006/main"/>
           <a:p xmlns:a="http://schemas.openxmlformats.org/drawingml/2006/main">
             <a:pPr algn="l">
+              <a:buNone/>
               <a:defRPr sz="1500" b="1">
                 <a:solidFill>
                   <a:srgbClr val="3D8DFF"/>
@@ -1659,6 +1660,7 @@
           <a:lstStyle xmlns:a="http://schemas.openxmlformats.org/drawingml/2006/main"/>
           <a:p xmlns:a="http://schemas.openxmlformats.org/drawingml/2006/main">
             <a:pPr algn="l">
+              <a:buNone/>
               <a:defRPr sz="4350" b="1">
                 <a:solidFill>
                   <a:srgbClr val="10121F"/>
@@ -1704,6 +1706,7 @@
           <a:lstStyle xmlns:a="http://schemas.openxmlformats.org/drawingml/2006/main"/>
           <a:p xmlns:a="http://schemas.openxmlformats.org/drawingml/2006/main">
             <a:pPr algn="l">
+              <a:buNone/>
               <a:defRPr sz="2100" b="0">
                 <a:solidFill>
                   <a:srgbClr val="5D6472"/>
@@ -1780,6 +1783,7 @@
           <a:lstStyle xmlns:a="http://schemas.openxmlformats.org/drawingml/2006/main"/>
           <a:p xmlns:a="http://schemas.openxmlformats.org/drawingml/2006/main">
             <a:pPr algn="l">
+              <a:buNone/>
               <a:defRPr sz="1500" b="1">
                 <a:solidFill>
                   <a:srgbClr val="10121F"/>
@@ -1825,6 +1829,7 @@
           <a:lstStyle xmlns:a="http://schemas.openxmlformats.org/drawingml/2006/main"/>
           <a:p xmlns:a="http://schemas.openxmlformats.org/drawingml/2006/main">
             <a:pPr algn="l">
+              <a:buNone/>
               <a:defRPr sz="1050" b="0">
                 <a:solidFill>
                   <a:srgbClr val="5D6472"/>
@@ -1901,6 +1906,7 @@
           <a:lstStyle xmlns:a="http://schemas.openxmlformats.org/drawingml/2006/main"/>
           <a:p xmlns:a="http://schemas.openxmlformats.org/drawingml/2006/main">
             <a:pPr algn="l">
+              <a:buNone/>
               <a:defRPr sz="900" b="1">
                 <a:solidFill>
                   <a:srgbClr val="5D6472"/>
@@ -1946,6 +1952,7 @@
           <a:lstStyle xmlns:a="http://schemas.openxmlformats.org/drawingml/2006/main"/>
           <a:p xmlns:a="http://schemas.openxmlformats.org/drawingml/2006/main">
             <a:pPr algn="r">
+              <a:buNone/>
               <a:defRPr sz="900" b="1">
                 <a:solidFill>
                   <a:srgbClr val="5D6472"/>
@@ -1963,28 +1970,23 @@
       </p:sp>
       <p:pic>
         <p:nvPicPr>
-          <p:cNvPr id="22" name=""/>
+          <p:cNvPr id="24" name=""/>
           <p:cNvPicPr>
             <a:picLocks xmlns:a="http://schemas.openxmlformats.org/drawingml/2006/main" noChangeAspect="1"/>
           </p:cNvPicPr>
           <p:nvPr/>
         </p:nvPicPr>
         <p:blipFill>
-          <a:blip xmlns:r="http://schemas.openxmlformats.org/officeDocument/2006/relationships" xmlns:a="http://schemas.openxmlformats.org/drawingml/2006/main" r:embed="R9903b8172d074e31"/>
-          <a:srcRect xmlns:a="http://schemas.openxmlformats.org/drawingml/2006/main" l="22835" t="0" r="22835" b="0"/>
-          <a:stretch xmlns:a="http://schemas.openxmlformats.org/drawingml/2006/main">
-            <a:fillRect l="0" t="0" r="0" b="0"/>
-          </a:stretch>
+          <a:blip xmlns:r="http://schemas.openxmlformats.org/officeDocument/2006/relationships" xmlns:a="http://schemas.openxmlformats.org/drawingml/2006/main" r:embed="R2118e2b13914450b"/>
+          <a:stretch xmlns:a="http://schemas.openxmlformats.org/drawingml/2006/main"/>
         </p:blipFill>
         <p:spPr>
-          <a:xfrm xmlns:a="http://schemas.openxmlformats.org/drawingml/2006/main">
-            <a:off x="6229350" y="495300"/>
-            <a:ext cx="5391150" cy="5581650"/>
+          <a:xfrm xmlns:a="http://schemas.openxmlformats.org/drawingml/2006/main" flipH="0" flipV="0">
+            <a:off x="6229350" y="1482747"/>
+            <a:ext cx="5391150" cy="3606755"/>
           </a:xfrm>
           <a:prstGeom xmlns:a="http://schemas.openxmlformats.org/drawingml/2006/main" prst="roundRect">
-            <a:avLst>
-              <a:gd name="adj" fmla="val 2120"/>
-            </a:avLst>
+            <a:avLst/>
           </a:prstGeom>
         </p:spPr>
       </p:pic>
@@ -2047,6 +2049,7 @@
           <a:lstStyle xmlns:a="http://schemas.openxmlformats.org/drawingml/2006/main"/>
           <a:p xmlns:a="http://schemas.openxmlformats.org/drawingml/2006/main">
             <a:pPr algn="l">
+              <a:buNone/>
               <a:defRPr sz="3300" b="1">
                 <a:solidFill>
                   <a:srgbClr val="10121F"/>
@@ -2092,6 +2095,7 @@
           <a:lstStyle xmlns:a="http://schemas.openxmlformats.org/drawingml/2006/main"/>
           <a:p xmlns:a="http://schemas.openxmlformats.org/drawingml/2006/main">
             <a:pPr algn="l">
+              <a:buNone/>
               <a:defRPr sz="1725" b="0">
                 <a:solidFill>
                   <a:srgbClr val="5D6472"/>
@@ -2207,6 +2211,7 @@
           <a:lstStyle xmlns:a="http://schemas.openxmlformats.org/drawingml/2006/main"/>
           <a:p xmlns:a="http://schemas.openxmlformats.org/drawingml/2006/main">
             <a:pPr algn="l">
+              <a:buNone/>
               <a:defRPr sz="1200" b="1">
                 <a:solidFill>
                   <a:srgbClr val="2F9D6A"/>
@@ -2252,6 +2257,7 @@
           <a:lstStyle xmlns:a="http://schemas.openxmlformats.org/drawingml/2006/main"/>
           <a:p xmlns:a="http://schemas.openxmlformats.org/drawingml/2006/main">
             <a:pPr algn="l">
+              <a:buNone/>
               <a:defRPr sz="3750" b="1">
                 <a:solidFill>
                   <a:srgbClr val="2F9D6A"/>
@@ -2297,6 +2303,7 @@
           <a:lstStyle xmlns:a="http://schemas.openxmlformats.org/drawingml/2006/main"/>
           <a:p xmlns:a="http://schemas.openxmlformats.org/drawingml/2006/main">
             <a:pPr algn="l">
+              <a:buNone/>
               <a:defRPr sz="1800" b="0">
                 <a:solidFill>
                   <a:srgbClr val="10121F"/>
@@ -2344,6 +2351,7 @@
           <a:lstStyle xmlns:a="http://schemas.openxmlformats.org/drawingml/2006/main"/>
           <a:p xmlns:a="http://schemas.openxmlformats.org/drawingml/2006/main">
             <a:pPr algn="l">
+              <a:buNone/>
               <a:defRPr sz="1200" b="1">
                 <a:solidFill>
                   <a:srgbClr val="C95048"/>
@@ -2389,6 +2397,7 @@
           <a:lstStyle xmlns:a="http://schemas.openxmlformats.org/drawingml/2006/main"/>
           <a:p xmlns:a="http://schemas.openxmlformats.org/drawingml/2006/main">
             <a:pPr algn="l">
+              <a:buNone/>
               <a:defRPr sz="3750" b="1">
                 <a:solidFill>
                   <a:srgbClr val="C95048"/>
@@ -2434,6 +2443,7 @@
           <a:lstStyle xmlns:a="http://schemas.openxmlformats.org/drawingml/2006/main"/>
           <a:p xmlns:a="http://schemas.openxmlformats.org/drawingml/2006/main">
             <a:pPr algn="l">
+              <a:buNone/>
               <a:defRPr sz="1800" b="0">
                 <a:solidFill>
                   <a:srgbClr val="10121F"/>
@@ -2444,7 +2454,10 @@
               </a:defRPr>
             </a:pPr>
             <a:r>
-              <a:t>Income &lt; INR 250,000
+              <a:t>Income ≤ INR 437,500</a:t>
+            </a:r>
+            <a:r>
+              <a:t>
 Age ≤ 25
 Disability exception missing</a:t>
             </a:r>
@@ -2481,6 +2494,7 @@
           <a:lstStyle xmlns:a="http://schemas.openxmlformats.org/drawingml/2006/main"/>
           <a:p xmlns:a="http://schemas.openxmlformats.org/drawingml/2006/main">
             <a:pPr algn="l">
+              <a:buNone/>
               <a:defRPr sz="1650" b="1">
                 <a:solidFill>
                   <a:srgbClr val="10121F"/>
@@ -2557,6 +2571,7 @@
           <a:lstStyle xmlns:a="http://schemas.openxmlformats.org/drawingml/2006/main"/>
           <a:p xmlns:a="http://schemas.openxmlformats.org/drawingml/2006/main">
             <a:pPr algn="l">
+              <a:buNone/>
               <a:defRPr sz="900" b="1">
                 <a:solidFill>
                   <a:srgbClr val="5D6472"/>
@@ -2602,6 +2617,7 @@
           <a:lstStyle xmlns:a="http://schemas.openxmlformats.org/drawingml/2006/main"/>
           <a:p xmlns:a="http://schemas.openxmlformats.org/drawingml/2006/main">
             <a:pPr algn="r">
+              <a:buNone/>
               <a:defRPr sz="900" b="1">
                 <a:solidFill>
                   <a:srgbClr val="5D6472"/>
@@ -2676,6 +2692,7 @@
           <a:lstStyle xmlns:a="http://schemas.openxmlformats.org/drawingml/2006/main"/>
           <a:p xmlns:a="http://schemas.openxmlformats.org/drawingml/2006/main">
             <a:pPr algn="l">
+              <a:buNone/>
               <a:defRPr sz="3225" b="1">
                 <a:solidFill>
                   <a:srgbClr val="10121F"/>
@@ -2721,6 +2738,7 @@
           <a:lstStyle xmlns:a="http://schemas.openxmlformats.org/drawingml/2006/main"/>
           <a:p xmlns:a="http://schemas.openxmlformats.org/drawingml/2006/main">
             <a:pPr algn="l">
+              <a:buNone/>
               <a:defRPr sz="1650" b="0">
                 <a:solidFill>
                   <a:srgbClr val="5D6472"/>
@@ -2832,6 +2850,7 @@
           <a:lstStyle xmlns:a="http://schemas.openxmlformats.org/drawingml/2006/main"/>
           <a:p xmlns:a="http://schemas.openxmlformats.org/drawingml/2006/main">
             <a:pPr algn="l">
+              <a:buNone/>
               <a:defRPr sz="900" b="1">
                 <a:solidFill>
                   <a:srgbClr val="5D6472"/>
@@ -2877,6 +2896,7 @@
           <a:lstStyle xmlns:a="http://schemas.openxmlformats.org/drawingml/2006/main"/>
           <a:p xmlns:a="http://schemas.openxmlformats.org/drawingml/2006/main">
             <a:pPr algn="r">
+              <a:buNone/>
               <a:defRPr sz="900" b="1">
                 <a:solidFill>
                   <a:srgbClr val="5D6472"/>
@@ -2894,14 +2914,14 @@
       </p:sp>
       <p:pic>
         <p:nvPicPr>
-          <p:cNvPr id="14" name=""/>
+          <p:cNvPr id="16" name=""/>
           <p:cNvPicPr>
             <a:picLocks xmlns:a="http://schemas.openxmlformats.org/drawingml/2006/main" noChangeAspect="1"/>
           </p:cNvPicPr>
           <p:nvPr/>
         </p:nvPicPr>
         <p:blipFill>
-          <a:blip xmlns:r="http://schemas.openxmlformats.org/officeDocument/2006/relationships" xmlns:a="http://schemas.openxmlformats.org/drawingml/2006/main" r:embed="Re154eb42aab74e95"/>
+          <a:blip xmlns:r="http://schemas.openxmlformats.org/officeDocument/2006/relationships" xmlns:a="http://schemas.openxmlformats.org/drawingml/2006/main" r:embed="Re9201d01185d48fe"/>
           <a:srcRect xmlns:a="http://schemas.openxmlformats.org/drawingml/2006/main" l="0" t="572" r="0" b="572"/>
           <a:stretch xmlns:a="http://schemas.openxmlformats.org/drawingml/2006/main">
             <a:fillRect l="0" t="0" r="0" b="0"/>
@@ -2978,6 +2998,7 @@
           <a:lstStyle xmlns:a="http://schemas.openxmlformats.org/drawingml/2006/main"/>
           <a:p xmlns:a="http://schemas.openxmlformats.org/drawingml/2006/main">
             <a:pPr algn="l">
+              <a:buNone/>
               <a:defRPr sz="3150" b="1">
                 <a:solidFill>
                   <a:srgbClr val="10121F"/>
@@ -3023,6 +3044,7 @@
           <a:lstStyle xmlns:a="http://schemas.openxmlformats.org/drawingml/2006/main"/>
           <a:p xmlns:a="http://schemas.openxmlformats.org/drawingml/2006/main">
             <a:pPr algn="l">
+              <a:buNone/>
               <a:defRPr sz="1650" b="0">
                 <a:solidFill>
                   <a:srgbClr val="5D6472"/>
@@ -3173,6 +3195,7 @@
           <a:lstStyle xmlns:a="http://schemas.openxmlformats.org/drawingml/2006/main"/>
           <a:p xmlns:a="http://schemas.openxmlformats.org/drawingml/2006/main">
             <a:pPr algn="l">
+              <a:buNone/>
               <a:defRPr sz="2250" b="1">
                 <a:solidFill>
                   <a:srgbClr val="3D8DFF"/>
@@ -3218,6 +3241,7 @@
           <a:lstStyle xmlns:a="http://schemas.openxmlformats.org/drawingml/2006/main"/>
           <a:p xmlns:a="http://schemas.openxmlformats.org/drawingml/2006/main">
             <a:pPr algn="l">
+              <a:buNone/>
               <a:defRPr sz="2325" b="1">
                 <a:solidFill>
                   <a:srgbClr val="10121F"/>
@@ -3263,6 +3287,7 @@
           <a:lstStyle xmlns:a="http://schemas.openxmlformats.org/drawingml/2006/main"/>
           <a:p xmlns:a="http://schemas.openxmlformats.org/drawingml/2006/main">
             <a:pPr algn="l">
+              <a:buNone/>
               <a:defRPr sz="1575" b="0">
                 <a:solidFill>
                   <a:srgbClr val="10121F"/>
@@ -3308,6 +3333,7 @@
           <a:lstStyle xmlns:a="http://schemas.openxmlformats.org/drawingml/2006/main"/>
           <a:p xmlns:a="http://schemas.openxmlformats.org/drawingml/2006/main">
             <a:pPr algn="l">
+              <a:buNone/>
               <a:defRPr sz="2250" b="1">
                 <a:solidFill>
                   <a:srgbClr val="3D8DFF"/>
@@ -3353,6 +3379,7 @@
           <a:lstStyle xmlns:a="http://schemas.openxmlformats.org/drawingml/2006/main"/>
           <a:p xmlns:a="http://schemas.openxmlformats.org/drawingml/2006/main">
             <a:pPr algn="l">
+              <a:buNone/>
               <a:defRPr sz="2325" b="1">
                 <a:solidFill>
                   <a:srgbClr val="10121F"/>
@@ -3398,6 +3425,7 @@
           <a:lstStyle xmlns:a="http://schemas.openxmlformats.org/drawingml/2006/main"/>
           <a:p xmlns:a="http://schemas.openxmlformats.org/drawingml/2006/main">
             <a:pPr algn="l">
+              <a:buNone/>
               <a:defRPr sz="1575" b="0">
                 <a:solidFill>
                   <a:srgbClr val="10121F"/>
@@ -3443,6 +3471,7 @@
           <a:lstStyle xmlns:a="http://schemas.openxmlformats.org/drawingml/2006/main"/>
           <a:p xmlns:a="http://schemas.openxmlformats.org/drawingml/2006/main">
             <a:pPr algn="l">
+              <a:buNone/>
               <a:defRPr sz="2250" b="1">
                 <a:solidFill>
                   <a:srgbClr val="3D8DFF"/>
@@ -3488,6 +3517,7 @@
           <a:lstStyle xmlns:a="http://schemas.openxmlformats.org/drawingml/2006/main"/>
           <a:p xmlns:a="http://schemas.openxmlformats.org/drawingml/2006/main">
             <a:pPr algn="l">
+              <a:buNone/>
               <a:defRPr sz="2325" b="1">
                 <a:solidFill>
                   <a:srgbClr val="10121F"/>
@@ -3533,6 +3563,7 @@
           <a:lstStyle xmlns:a="http://schemas.openxmlformats.org/drawingml/2006/main"/>
           <a:p xmlns:a="http://schemas.openxmlformats.org/drawingml/2006/main">
             <a:pPr algn="l">
+              <a:buNone/>
               <a:defRPr sz="1575" b="0">
                 <a:solidFill>
                   <a:srgbClr val="10121F"/>
@@ -3578,6 +3609,7 @@
           <a:lstStyle xmlns:a="http://schemas.openxmlformats.org/drawingml/2006/main"/>
           <a:p xmlns:a="http://schemas.openxmlformats.org/drawingml/2006/main">
             <a:pPr algn="l">
+              <a:buNone/>
               <a:defRPr sz="1275" b="1">
                 <a:solidFill>
                   <a:srgbClr val="5D6472"/>
@@ -3654,6 +3686,7 @@
           <a:lstStyle xmlns:a="http://schemas.openxmlformats.org/drawingml/2006/main"/>
           <a:p xmlns:a="http://schemas.openxmlformats.org/drawingml/2006/main">
             <a:pPr algn="l">
+              <a:buNone/>
               <a:defRPr sz="900" b="1">
                 <a:solidFill>
                   <a:srgbClr val="5D6472"/>
@@ -3699,6 +3732,7 @@
           <a:lstStyle xmlns:a="http://schemas.openxmlformats.org/drawingml/2006/main"/>
           <a:p xmlns:a="http://schemas.openxmlformats.org/drawingml/2006/main">
             <a:pPr algn="r">
+              <a:buNone/>
               <a:defRPr sz="900" b="1">
                 <a:solidFill>
                   <a:srgbClr val="5D6472"/>
@@ -3773,6 +3807,7 @@
           <a:lstStyle xmlns:a="http://schemas.openxmlformats.org/drawingml/2006/main"/>
           <a:p xmlns:a="http://schemas.openxmlformats.org/drawingml/2006/main">
             <a:pPr algn="l">
+              <a:buNone/>
               <a:defRPr sz="3300" b="1">
                 <a:solidFill>
                   <a:srgbClr val="10121F"/>
@@ -3818,6 +3853,7 @@
           <a:lstStyle xmlns:a="http://schemas.openxmlformats.org/drawingml/2006/main"/>
           <a:p xmlns:a="http://schemas.openxmlformats.org/drawingml/2006/main">
             <a:pPr algn="l">
+              <a:buNone/>
               <a:defRPr sz="1650" b="0">
                 <a:solidFill>
                   <a:srgbClr val="5D6472"/>
@@ -3894,6 +3930,7 @@
           <a:lstStyle xmlns:a="http://schemas.openxmlformats.org/drawingml/2006/main"/>
           <a:p xmlns:a="http://schemas.openxmlformats.org/drawingml/2006/main">
             <a:pPr algn="l">
+              <a:buNone/>
               <a:defRPr sz="900" b="1">
                 <a:solidFill>
                   <a:srgbClr val="5D6472"/>
@@ -3939,6 +3976,7 @@
           <a:lstStyle xmlns:a="http://schemas.openxmlformats.org/drawingml/2006/main"/>
           <a:p xmlns:a="http://schemas.openxmlformats.org/drawingml/2006/main">
             <a:pPr algn="r">
+              <a:buNone/>
               <a:defRPr sz="900" b="1">
                 <a:solidFill>
                   <a:srgbClr val="5D6472"/>
@@ -4019,6 +4057,7 @@
           <a:lstStyle xmlns:a="http://schemas.openxmlformats.org/drawingml/2006/main"/>
           <a:p xmlns:a="http://schemas.openxmlformats.org/drawingml/2006/main">
             <a:pPr algn="l">
+              <a:buNone/>
               <a:defRPr sz="1350" b="1">
                 <a:solidFill>
                   <a:srgbClr val="3D8DFF"/>
@@ -4064,6 +4103,7 @@
           <a:lstStyle xmlns:a="http://schemas.openxmlformats.org/drawingml/2006/main"/>
           <a:p xmlns:a="http://schemas.openxmlformats.org/drawingml/2006/main">
             <a:pPr algn="l">
+              <a:buNone/>
               <a:defRPr sz="1875" b="1">
                 <a:solidFill>
                   <a:srgbClr val="10121F"/>
@@ -4109,6 +4149,7 @@
           <a:lstStyle xmlns:a="http://schemas.openxmlformats.org/drawingml/2006/main"/>
           <a:p xmlns:a="http://schemas.openxmlformats.org/drawingml/2006/main">
             <a:pPr algn="l">
+              <a:buNone/>
               <a:defRPr sz="1425" b="0">
                 <a:solidFill>
                   <a:srgbClr val="5D6472"/>
@@ -4189,6 +4230,7 @@
           <a:lstStyle xmlns:a="http://schemas.openxmlformats.org/drawingml/2006/main"/>
           <a:p xmlns:a="http://schemas.openxmlformats.org/drawingml/2006/main">
             <a:pPr algn="l">
+              <a:buNone/>
               <a:defRPr sz="1350" b="1">
                 <a:solidFill>
                   <a:srgbClr val="3D8DFF"/>
@@ -4234,6 +4276,7 @@
           <a:lstStyle xmlns:a="http://schemas.openxmlformats.org/drawingml/2006/main"/>
           <a:p xmlns:a="http://schemas.openxmlformats.org/drawingml/2006/main">
             <a:pPr algn="l">
+              <a:buNone/>
               <a:defRPr sz="1875" b="1">
                 <a:solidFill>
                   <a:srgbClr val="10121F"/>
@@ -4279,6 +4322,7 @@
           <a:lstStyle xmlns:a="http://schemas.openxmlformats.org/drawingml/2006/main"/>
           <a:p xmlns:a="http://schemas.openxmlformats.org/drawingml/2006/main">
             <a:pPr algn="l">
+              <a:buNone/>
               <a:defRPr sz="1425" b="0">
                 <a:solidFill>
                   <a:srgbClr val="5D6472"/>
@@ -4359,6 +4403,7 @@
           <a:lstStyle xmlns:a="http://schemas.openxmlformats.org/drawingml/2006/main"/>
           <a:p xmlns:a="http://schemas.openxmlformats.org/drawingml/2006/main">
             <a:pPr algn="l">
+              <a:buNone/>
               <a:defRPr sz="1350" b="1">
                 <a:solidFill>
                   <a:srgbClr val="3D8DFF"/>
@@ -4404,6 +4449,7 @@
           <a:lstStyle xmlns:a="http://schemas.openxmlformats.org/drawingml/2006/main"/>
           <a:p xmlns:a="http://schemas.openxmlformats.org/drawingml/2006/main">
             <a:pPr algn="l">
+              <a:buNone/>
               <a:defRPr sz="1875" b="1">
                 <a:solidFill>
                   <a:srgbClr val="10121F"/>
@@ -4449,6 +4495,7 @@
           <a:lstStyle xmlns:a="http://schemas.openxmlformats.org/drawingml/2006/main"/>
           <a:p xmlns:a="http://schemas.openxmlformats.org/drawingml/2006/main">
             <a:pPr algn="l">
+              <a:buNone/>
               <a:defRPr sz="1425" b="0">
                 <a:solidFill>
                   <a:srgbClr val="5D6472"/>
@@ -4529,6 +4576,7 @@
           <a:lstStyle xmlns:a="http://schemas.openxmlformats.org/drawingml/2006/main"/>
           <a:p xmlns:a="http://schemas.openxmlformats.org/drawingml/2006/main">
             <a:pPr algn="l">
+              <a:buNone/>
               <a:defRPr sz="1350" b="1">
                 <a:solidFill>
                   <a:srgbClr val="3D8DFF"/>
@@ -4574,6 +4622,7 @@
           <a:lstStyle xmlns:a="http://schemas.openxmlformats.org/drawingml/2006/main"/>
           <a:p xmlns:a="http://schemas.openxmlformats.org/drawingml/2006/main">
             <a:pPr algn="l">
+              <a:buNone/>
               <a:defRPr sz="1875" b="1">
                 <a:solidFill>
                   <a:srgbClr val="10121F"/>
@@ -4619,6 +4668,7 @@
           <a:lstStyle xmlns:a="http://schemas.openxmlformats.org/drawingml/2006/main"/>
           <a:p xmlns:a="http://schemas.openxmlformats.org/drawingml/2006/main">
             <a:pPr algn="l">
+              <a:buNone/>
               <a:defRPr sz="1425" b="0">
                 <a:solidFill>
                   <a:srgbClr val="5D6472"/>
@@ -4693,6 +4743,7 @@
           <a:lstStyle xmlns:a="http://schemas.openxmlformats.org/drawingml/2006/main"/>
           <a:p xmlns:a="http://schemas.openxmlformats.org/drawingml/2006/main">
             <a:pPr algn="l">
+              <a:buNone/>
               <a:defRPr sz="3300" b="1">
                 <a:solidFill>
                   <a:srgbClr val="10121F"/>
@@ -4738,6 +4789,7 @@
           <a:lstStyle xmlns:a="http://schemas.openxmlformats.org/drawingml/2006/main"/>
           <a:p xmlns:a="http://schemas.openxmlformats.org/drawingml/2006/main">
             <a:pPr algn="l">
+              <a:buNone/>
               <a:defRPr sz="1650" b="0">
                 <a:solidFill>
                   <a:srgbClr val="5D6472"/>
@@ -4814,6 +4866,7 @@
           <a:lstStyle xmlns:a="http://schemas.openxmlformats.org/drawingml/2006/main"/>
           <a:p xmlns:a="http://schemas.openxmlformats.org/drawingml/2006/main">
             <a:pPr algn="l">
+              <a:buNone/>
               <a:defRPr sz="900" b="1">
                 <a:solidFill>
                   <a:srgbClr val="5D6472"/>
@@ -4859,6 +4912,7 @@
           <a:lstStyle xmlns:a="http://schemas.openxmlformats.org/drawingml/2006/main"/>
           <a:p xmlns:a="http://schemas.openxmlformats.org/drawingml/2006/main">
             <a:pPr algn="r">
+              <a:buNone/>
               <a:defRPr sz="900" b="1">
                 <a:solidFill>
                   <a:srgbClr val="5D6472"/>
@@ -4939,6 +4993,7 @@
           <a:lstStyle xmlns:a="http://schemas.openxmlformats.org/drawingml/2006/main"/>
           <a:p xmlns:a="http://schemas.openxmlformats.org/drawingml/2006/main">
             <a:pPr algn="l">
+              <a:buNone/>
               <a:defRPr sz="4650" b="1">
                 <a:solidFill>
                   <a:srgbClr val="10121F"/>
@@ -5015,6 +5070,7 @@
           <a:lstStyle xmlns:a="http://schemas.openxmlformats.org/drawingml/2006/main"/>
           <a:p xmlns:a="http://schemas.openxmlformats.org/drawingml/2006/main">
             <a:pPr algn="l">
+              <a:buNone/>
               <a:defRPr sz="1575" b="0">
                 <a:solidFill>
                   <a:srgbClr val="5D6472"/>
@@ -5096,6 +5152,7 @@
           <a:lstStyle xmlns:a="http://schemas.openxmlformats.org/drawingml/2006/main"/>
           <a:p xmlns:a="http://schemas.openxmlformats.org/drawingml/2006/main">
             <a:pPr algn="l">
+              <a:buNone/>
               <a:defRPr sz="4650" b="1">
                 <a:solidFill>
                   <a:srgbClr val="3D8DFF"/>
@@ -5172,6 +5229,7 @@
           <a:lstStyle xmlns:a="http://schemas.openxmlformats.org/drawingml/2006/main"/>
           <a:p xmlns:a="http://schemas.openxmlformats.org/drawingml/2006/main">
             <a:pPr algn="l">
+              <a:buNone/>
               <a:defRPr sz="1575" b="0">
                 <a:solidFill>
                   <a:srgbClr val="5D6472"/>
@@ -5253,6 +5311,7 @@
           <a:lstStyle xmlns:a="http://schemas.openxmlformats.org/drawingml/2006/main"/>
           <a:p xmlns:a="http://schemas.openxmlformats.org/drawingml/2006/main">
             <a:pPr algn="l">
+              <a:buNone/>
               <a:defRPr sz="4650" b="1">
                 <a:solidFill>
                   <a:srgbClr val="10121F"/>
@@ -5329,6 +5388,7 @@
           <a:lstStyle xmlns:a="http://schemas.openxmlformats.org/drawingml/2006/main"/>
           <a:p xmlns:a="http://schemas.openxmlformats.org/drawingml/2006/main">
             <a:pPr algn="l">
+              <a:buNone/>
               <a:defRPr sz="1575" b="0">
                 <a:solidFill>
                   <a:srgbClr val="5D6472"/>
@@ -5404,6 +5464,7 @@
           <a:lstStyle xmlns:a="http://schemas.openxmlformats.org/drawingml/2006/main"/>
           <a:p xmlns:a="http://schemas.openxmlformats.org/drawingml/2006/main">
             <a:pPr algn="l">
+              <a:buNone/>
               <a:defRPr sz="1350" b="1">
                 <a:solidFill>
                   <a:srgbClr val="3D8DFF"/>
@@ -5449,6 +5510,7 @@
           <a:lstStyle xmlns:a="http://schemas.openxmlformats.org/drawingml/2006/main"/>
           <a:p xmlns:a="http://schemas.openxmlformats.org/drawingml/2006/main">
             <a:pPr algn="l">
+              <a:buNone/>
               <a:defRPr sz="5700" b="1">
                 <a:solidFill>
                   <a:srgbClr val="10121F"/>
@@ -5494,6 +5556,7 @@
           <a:lstStyle xmlns:a="http://schemas.openxmlformats.org/drawingml/2006/main"/>
           <a:p xmlns:a="http://schemas.openxmlformats.org/drawingml/2006/main">
             <a:pPr algn="l">
+              <a:buNone/>
               <a:defRPr sz="2100" b="0">
                 <a:solidFill>
                   <a:srgbClr val="5D6472"/>
@@ -5570,6 +5633,7 @@
           <a:lstStyle xmlns:a="http://schemas.openxmlformats.org/drawingml/2006/main"/>
           <a:p xmlns:a="http://schemas.openxmlformats.org/drawingml/2006/main">
             <a:pPr algn="l">
+              <a:buNone/>
               <a:defRPr sz="1200" b="1">
                 <a:solidFill>
                   <a:srgbClr val="10121F"/>
@@ -5646,6 +5710,7 @@
           <a:lstStyle xmlns:a="http://schemas.openxmlformats.org/drawingml/2006/main"/>
           <a:p xmlns:a="http://schemas.openxmlformats.org/drawingml/2006/main">
             <a:pPr algn="l">
+              <a:buNone/>
               <a:defRPr sz="900" b="1">
                 <a:solidFill>
                   <a:srgbClr val="5D6472"/>
@@ -5691,6 +5756,7 @@
           <a:lstStyle xmlns:a="http://schemas.openxmlformats.org/drawingml/2006/main"/>
           <a:p xmlns:a="http://schemas.openxmlformats.org/drawingml/2006/main">
             <a:pPr algn="r">
+              <a:buNone/>
               <a:defRPr sz="900" b="1">
                 <a:solidFill>
                   <a:srgbClr val="5D6472"/>

</xml_diff>